<commit_message>
Slides: bare prop added to the membrane slide with its thrust (3.75 N) against the quietest other set-up (0.39 N)
Co-Authored-By: Claude Sonnet 5.5 <noreply@anthropic.com>
</commit_message>
<xml_diff>
--- a/docs/analysis/chamber-final-2026-10-01/slides/2026-10-09 duct membrane materials results.pptx
+++ b/docs/analysis/chamber-final-2026-10-01/slides/2026-10-09 duct membrane materials results.pptx
@@ -502,7 +502,7 @@
           <a:p>
             <a:r>
               <a:rPr lang="en-US" dirty="0"/>
-              <a:t>Bases in the data repo (f30__5in3b__membrane-...): 8 Oct 2026: membrane-duct-small, membrane-open-pore-pu-foam. 9 Oct 2026: membrane-duct-open-pore-pu-foam-double-layer, membrane-felt, membrane-felt-double-layer, membrane-cork, membrane-felt-rubber, membrane-thinsulate-8-layers, -4-layers, -2-layers. Each base was captured with 3 repeats of the ramp; the plot uses the PWM 2000 step and the mean over the 3 repeats of the total level 500 Hz to 24 kHz per microphone, in dB SPL, read with the corrected microphone files. The repeat-to-repeat scatter of the mean level is 0.02-0.11 dB. There is no bare reference measured with this set-up (the base names carry a different motor field, f30, from the 2 and 7 Oct materials), so levels here are not comparable with slide 8 and no louder-than-bare figure is given; the callout is the difference between the quietest (best: Thinsulate, 4 layers) and the loudest (worst: duct, membrane only) set-up: 10.2 dB at its largest, at +18°, and 6.7 dB on average over the eleven microphones. Per angle the difference runs from 4.1 dB at -90 degrees to 10.2 dB at +18 degrees; the largest spread across all ten set-ups at a single angle is the same 10.2 dB. Two of the bases are ducts. The polar is mirrored to 360 degrees.</a:t>
+              <a:t>Bases in the data repo (f30__5in3b__membrane-...): 8 Oct 2026: membrane-duct-small, membrane-open-pore-pu-foam. 9 Oct 2026: membrane-duct-open-pore-pu-foam-double-layer, membrane-felt, membrane-felt-double-layer, membrane-cork, membrane-felt-rubber, membrane-thinsulate-8-layers, -4-layers, -2-layers. Each base was captured with 3 repeats of the ramp; the plot uses the PWM 2000 step and the mean over the 3 repeats of the total level 500 Hz to 24 kHz per microphone, in dB SPL, read with the corrected microphone files. The repeat-to-repeat scatter of the mean level is 0.02-0.11 dB. The bare prop (base f30__5in3b__unset__v1-bare-prop, 9 Oct 16:10, 3 repeats) is the reference for this set-up and the quietest curve on average (75.1 dB), 7.7 dB below the quietest membrane set-up on average, but at -90 degrees it is 87.7 dB, level with the others. Thrust at 2000 us (median of the second half of each step, mean of 3 repeats, magnitude; the stand reads negative): bare prop 3.75 N; membrane set-ups 0.37-1.19 N (Thinsulate 2 layers 0.37, Thinsulate 4 layers 0.39, felt double 0.88, felt 0.95, duct membrane only 0.97, PU foam 1.03, duct + PU foam double 1.03, felt + rubber 1.09, Thinsulate 8 layers 1.10, cork 1.19), so every membrane set-up delivers 10-32 % of the bare thrust and the levels are not at equal thrust. Levels here are not comparable with slide 8 (different motor field in the base name, f30). The callout is the difference between the quietest (best: Thinsulate, 4 layers) and the loudest (worst: duct, membrane only) set-up: 10.2 dB at its largest, at +18°, and 6.7 dB on average over the eleven microphones. Per angle the difference runs from 4.1 dB at -90 degrees to 10.2 dB at +18 degrees; the largest spread across all ten set-ups at a single angle is the same 10.2 dB. Two of the bases are ducts. The polar is mirrored to 360 degrees.</a:t>
             </a:r>
             <a:endParaRPr lang="en-US" dirty="0"/>
           </a:p>
@@ -1024,8 +1024,150 @@
         </p:nvSpPr>
         <p:spPr>
           <a:xfrm>
-            <a:off x="6583680" y="1938528"/>
-            <a:ext cx="182880" cy="182880"/>
+            <a:off x="6583680" y="1837944"/>
+            <a:ext cx="164592" cy="164592"/>
+          </a:xfrm>
+          <a:prstGeom prst="ellipse">
+            <a:avLst/>
+          </a:prstGeom>
+          <a:solidFill>
+            <a:srgbClr val="000000"/>
+          </a:solidFill>
+          <a:ln w="12700">
+            <a:solidFill>
+              <a:srgbClr val="000000"/>
+            </a:solidFill>
+            <a:prstDash val="solid"/>
+          </a:ln>
+        </p:spPr>
+      </p:sp>
+      <p:sp>
+        <p:nvSpPr>
+          <p:cNvPr id="7" name="Text 4"/>
+          <p:cNvSpPr txBox="1"/>
+          <p:nvPr/>
+        </p:nvSpPr>
+        <p:spPr>
+          <a:xfrm>
+            <a:off x="6858000" y="1783080"/>
+            <a:ext cx="2834640" cy="274320"/>
+          </a:xfrm>
+          <a:prstGeom prst="rect">
+            <a:avLst/>
+          </a:prstGeom>
+          <a:noFill/>
+          <a:ln/>
+        </p:spPr>
+        <p:txBody>
+          <a:bodyPr wrap="square" lIns="0" tIns="0" rIns="0" bIns="0" rtlCol="0" anchor="ctr"/>
+          <a:lstStyle/>
+          <a:p>
+            <a:pPr indent="0" marL="0">
+              <a:buNone/>
+            </a:pPr>
+            <a:r>
+              <a:rPr lang="en-US" sz="1400" b="1" dirty="0">
+                <a:solidFill>
+                  <a:srgbClr val="1F2A44"/>
+                </a:solidFill>
+                <a:latin typeface="Calibri" pitchFamily="34" charset="0"/>
+                <a:ea typeface="Calibri" pitchFamily="34" charset="-122"/>
+                <a:cs typeface="Calibri" pitchFamily="34" charset="-120"/>
+              </a:rPr>
+              <a:t>Bare prop</a:t>
+            </a:r>
+            <a:endParaRPr lang="en-US" sz="1400" dirty="0"/>
+          </a:p>
+        </p:txBody>
+      </p:sp>
+      <p:sp>
+        <p:nvSpPr>
+          <p:cNvPr id="8" name="Text 5"/>
+          <p:cNvSpPr txBox="1"/>
+          <p:nvPr/>
+        </p:nvSpPr>
+        <p:spPr>
+          <a:xfrm>
+            <a:off x="9692640" y="1783080"/>
+            <a:ext cx="640080" cy="274320"/>
+          </a:xfrm>
+          <a:prstGeom prst="rect">
+            <a:avLst/>
+          </a:prstGeom>
+          <a:noFill/>
+          <a:ln/>
+        </p:spPr>
+        <p:txBody>
+          <a:bodyPr wrap="square" lIns="0" tIns="0" rIns="0" bIns="0" rtlCol="0" anchor="ctr"/>
+          <a:lstStyle/>
+          <a:p>
+            <a:pPr indent="0" marL="0">
+              <a:buNone/>
+            </a:pPr>
+            <a:r>
+              <a:rPr lang="en-US" sz="1200" dirty="0">
+                <a:solidFill>
+                  <a:srgbClr val="5B6578"/>
+                </a:solidFill>
+                <a:latin typeface="Calibri" pitchFamily="34" charset="0"/>
+                <a:ea typeface="Calibri" pitchFamily="34" charset="-122"/>
+                <a:cs typeface="Calibri" pitchFamily="34" charset="-120"/>
+              </a:rPr>
+              <a:t>9 Oct</a:t>
+            </a:r>
+            <a:endParaRPr lang="en-US" sz="1200" dirty="0"/>
+          </a:p>
+        </p:txBody>
+      </p:sp>
+      <p:sp>
+        <p:nvSpPr>
+          <p:cNvPr id="9" name="Text 6"/>
+          <p:cNvSpPr txBox="1"/>
+          <p:nvPr/>
+        </p:nvSpPr>
+        <p:spPr>
+          <a:xfrm>
+            <a:off x="10241280" y="1783080"/>
+            <a:ext cx="1463040" cy="274320"/>
+          </a:xfrm>
+          <a:prstGeom prst="rect">
+            <a:avLst/>
+          </a:prstGeom>
+          <a:noFill/>
+          <a:ln/>
+        </p:spPr>
+        <p:txBody>
+          <a:bodyPr wrap="square" lIns="0" tIns="0" rIns="0" bIns="0" rtlCol="0" anchor="ctr"/>
+          <a:lstStyle/>
+          <a:p>
+            <a:pPr algn="r" indent="0" marL="0">
+              <a:buNone/>
+            </a:pPr>
+            <a:r>
+              <a:rPr lang="en-US" sz="1400" dirty="0">
+                <a:solidFill>
+                  <a:srgbClr val="1F2A44"/>
+                </a:solidFill>
+                <a:latin typeface="Calibri" pitchFamily="34" charset="0"/>
+                <a:ea typeface="Calibri" pitchFamily="34" charset="-122"/>
+                <a:cs typeface="Calibri" pitchFamily="34" charset="-120"/>
+              </a:rPr>
+              <a:t>75.1 dB</a:t>
+            </a:r>
+            <a:endParaRPr lang="en-US" sz="1400" dirty="0"/>
+          </a:p>
+        </p:txBody>
+      </p:sp>
+      <p:sp>
+        <p:nvSpPr>
+          <p:cNvPr id="10" name="Shape 7"/>
+          <p:cNvSpPr/>
+          <p:nvPr/>
+        </p:nvSpPr>
+        <p:spPr>
+          <a:xfrm>
+            <a:off x="6583680" y="2125980"/>
+            <a:ext cx="164592" cy="164592"/>
           </a:xfrm>
           <a:prstGeom prst="ellipse">
             <a:avLst/>
@@ -1043,14 +1185,14 @@
       </p:sp>
       <p:sp>
         <p:nvSpPr>
-          <p:cNvPr id="7" name="Text 4"/>
-          <p:cNvSpPr txBox="1"/>
-          <p:nvPr/>
-        </p:nvSpPr>
-        <p:spPr>
-          <a:xfrm>
-            <a:off x="6858000" y="1874520"/>
-            <a:ext cx="2834640" cy="310896"/>
+          <p:cNvPr id="11" name="Text 8"/>
+          <p:cNvSpPr txBox="1"/>
+          <p:nvPr/>
+        </p:nvSpPr>
+        <p:spPr>
+          <a:xfrm>
+            <a:off x="6858000" y="2071116"/>
+            <a:ext cx="2834640" cy="274320"/>
           </a:xfrm>
           <a:prstGeom prst="rect">
             <a:avLst/>
@@ -1082,14 +1224,14 @@
       </p:sp>
       <p:sp>
         <p:nvSpPr>
-          <p:cNvPr id="8" name="Text 5"/>
-          <p:cNvSpPr txBox="1"/>
-          <p:nvPr/>
-        </p:nvSpPr>
-        <p:spPr>
-          <a:xfrm>
-            <a:off x="9692640" y="1874520"/>
-            <a:ext cx="640080" cy="310896"/>
+          <p:cNvPr id="12" name="Text 9"/>
+          <p:cNvSpPr txBox="1"/>
+          <p:nvPr/>
+        </p:nvSpPr>
+        <p:spPr>
+          <a:xfrm>
+            <a:off x="9692640" y="2071116"/>
+            <a:ext cx="640080" cy="274320"/>
           </a:xfrm>
           <a:prstGeom prst="rect">
             <a:avLst/>
@@ -1121,14 +1263,14 @@
       </p:sp>
       <p:sp>
         <p:nvSpPr>
-          <p:cNvPr id="9" name="Text 6"/>
-          <p:cNvSpPr txBox="1"/>
-          <p:nvPr/>
-        </p:nvSpPr>
-        <p:spPr>
-          <a:xfrm>
-            <a:off x="10241280" y="1874520"/>
-            <a:ext cx="1463040" cy="310896"/>
+          <p:cNvPr id="13" name="Text 10"/>
+          <p:cNvSpPr txBox="1"/>
+          <p:nvPr/>
+        </p:nvSpPr>
+        <p:spPr>
+          <a:xfrm>
+            <a:off x="10241280" y="2071116"/>
+            <a:ext cx="1463040" cy="274320"/>
           </a:xfrm>
           <a:prstGeom prst="rect">
             <a:avLst/>
@@ -1160,14 +1302,14 @@
       </p:sp>
       <p:sp>
         <p:nvSpPr>
-          <p:cNvPr id="10" name="Shape 7"/>
+          <p:cNvPr id="14" name="Shape 11"/>
           <p:cNvSpPr/>
           <p:nvPr/>
         </p:nvSpPr>
         <p:spPr>
           <a:xfrm>
-            <a:off x="6583680" y="2276856"/>
-            <a:ext cx="182880" cy="182880"/>
+            <a:off x="6583680" y="2414016"/>
+            <a:ext cx="164592" cy="164592"/>
           </a:xfrm>
           <a:prstGeom prst="ellipse">
             <a:avLst/>
@@ -1185,14 +1327,14 @@
       </p:sp>
       <p:sp>
         <p:nvSpPr>
-          <p:cNvPr id="11" name="Text 8"/>
-          <p:cNvSpPr txBox="1"/>
-          <p:nvPr/>
-        </p:nvSpPr>
-        <p:spPr>
-          <a:xfrm>
-            <a:off x="6858000" y="2212848"/>
-            <a:ext cx="2834640" cy="310896"/>
+          <p:cNvPr id="15" name="Text 12"/>
+          <p:cNvSpPr txBox="1"/>
+          <p:nvPr/>
+        </p:nvSpPr>
+        <p:spPr>
+          <a:xfrm>
+            <a:off x="6858000" y="2359152"/>
+            <a:ext cx="2834640" cy="274320"/>
           </a:xfrm>
           <a:prstGeom prst="rect">
             <a:avLst/>
@@ -1224,14 +1366,14 @@
       </p:sp>
       <p:sp>
         <p:nvSpPr>
-          <p:cNvPr id="12" name="Text 9"/>
-          <p:cNvSpPr txBox="1"/>
-          <p:nvPr/>
-        </p:nvSpPr>
-        <p:spPr>
-          <a:xfrm>
-            <a:off x="9692640" y="2212848"/>
-            <a:ext cx="640080" cy="310896"/>
+          <p:cNvPr id="16" name="Text 13"/>
+          <p:cNvSpPr txBox="1"/>
+          <p:nvPr/>
+        </p:nvSpPr>
+        <p:spPr>
+          <a:xfrm>
+            <a:off x="9692640" y="2359152"/>
+            <a:ext cx="640080" cy="274320"/>
           </a:xfrm>
           <a:prstGeom prst="rect">
             <a:avLst/>
@@ -1263,14 +1405,14 @@
       </p:sp>
       <p:sp>
         <p:nvSpPr>
-          <p:cNvPr id="13" name="Text 10"/>
-          <p:cNvSpPr txBox="1"/>
-          <p:nvPr/>
-        </p:nvSpPr>
-        <p:spPr>
-          <a:xfrm>
-            <a:off x="10241280" y="2212848"/>
-            <a:ext cx="1463040" cy="310896"/>
+          <p:cNvPr id="17" name="Text 14"/>
+          <p:cNvSpPr txBox="1"/>
+          <p:nvPr/>
+        </p:nvSpPr>
+        <p:spPr>
+          <a:xfrm>
+            <a:off x="10241280" y="2359152"/>
+            <a:ext cx="1463040" cy="274320"/>
           </a:xfrm>
           <a:prstGeom prst="rect">
             <a:avLst/>
@@ -1302,14 +1444,14 @@
       </p:sp>
       <p:sp>
         <p:nvSpPr>
-          <p:cNvPr id="14" name="Shape 11"/>
+          <p:cNvPr id="18" name="Shape 15"/>
           <p:cNvSpPr/>
           <p:nvPr/>
         </p:nvSpPr>
         <p:spPr>
           <a:xfrm>
-            <a:off x="6583680" y="2615184"/>
-            <a:ext cx="182880" cy="182880"/>
+            <a:off x="6583680" y="2702052"/>
+            <a:ext cx="164592" cy="164592"/>
           </a:xfrm>
           <a:prstGeom prst="ellipse">
             <a:avLst/>
@@ -1327,14 +1469,14 @@
       </p:sp>
       <p:sp>
         <p:nvSpPr>
-          <p:cNvPr id="15" name="Text 12"/>
-          <p:cNvSpPr txBox="1"/>
-          <p:nvPr/>
-        </p:nvSpPr>
-        <p:spPr>
-          <a:xfrm>
-            <a:off x="6858000" y="2551176"/>
-            <a:ext cx="2834640" cy="310896"/>
+          <p:cNvPr id="19" name="Text 16"/>
+          <p:cNvSpPr txBox="1"/>
+          <p:nvPr/>
+        </p:nvSpPr>
+        <p:spPr>
+          <a:xfrm>
+            <a:off x="6858000" y="2647188"/>
+            <a:ext cx="2834640" cy="274320"/>
           </a:xfrm>
           <a:prstGeom prst="rect">
             <a:avLst/>
@@ -1366,14 +1508,14 @@
       </p:sp>
       <p:sp>
         <p:nvSpPr>
-          <p:cNvPr id="16" name="Text 13"/>
-          <p:cNvSpPr txBox="1"/>
-          <p:nvPr/>
-        </p:nvSpPr>
-        <p:spPr>
-          <a:xfrm>
-            <a:off x="9692640" y="2551176"/>
-            <a:ext cx="640080" cy="310896"/>
+          <p:cNvPr id="20" name="Text 17"/>
+          <p:cNvSpPr txBox="1"/>
+          <p:nvPr/>
+        </p:nvSpPr>
+        <p:spPr>
+          <a:xfrm>
+            <a:off x="9692640" y="2647188"/>
+            <a:ext cx="640080" cy="274320"/>
           </a:xfrm>
           <a:prstGeom prst="rect">
             <a:avLst/>
@@ -1405,14 +1547,14 @@
       </p:sp>
       <p:sp>
         <p:nvSpPr>
-          <p:cNvPr id="17" name="Text 14"/>
-          <p:cNvSpPr txBox="1"/>
-          <p:nvPr/>
-        </p:nvSpPr>
-        <p:spPr>
-          <a:xfrm>
-            <a:off x="10241280" y="2551176"/>
-            <a:ext cx="1463040" cy="310896"/>
+          <p:cNvPr id="21" name="Text 18"/>
+          <p:cNvSpPr txBox="1"/>
+          <p:nvPr/>
+        </p:nvSpPr>
+        <p:spPr>
+          <a:xfrm>
+            <a:off x="10241280" y="2647188"/>
+            <a:ext cx="1463040" cy="274320"/>
           </a:xfrm>
           <a:prstGeom prst="rect">
             <a:avLst/>
@@ -1444,14 +1586,14 @@
       </p:sp>
       <p:sp>
         <p:nvSpPr>
-          <p:cNvPr id="18" name="Shape 15"/>
+          <p:cNvPr id="22" name="Shape 19"/>
           <p:cNvSpPr/>
           <p:nvPr/>
         </p:nvSpPr>
         <p:spPr>
           <a:xfrm>
-            <a:off x="6583680" y="2953512"/>
-            <a:ext cx="182880" cy="182880"/>
+            <a:off x="6583680" y="2990088"/>
+            <a:ext cx="164592" cy="164592"/>
           </a:xfrm>
           <a:prstGeom prst="ellipse">
             <a:avLst/>
@@ -1469,14 +1611,14 @@
       </p:sp>
       <p:sp>
         <p:nvSpPr>
-          <p:cNvPr id="19" name="Text 16"/>
-          <p:cNvSpPr txBox="1"/>
-          <p:nvPr/>
-        </p:nvSpPr>
-        <p:spPr>
-          <a:xfrm>
-            <a:off x="6858000" y="2889504"/>
-            <a:ext cx="2834640" cy="310896"/>
+          <p:cNvPr id="23" name="Text 20"/>
+          <p:cNvSpPr txBox="1"/>
+          <p:nvPr/>
+        </p:nvSpPr>
+        <p:spPr>
+          <a:xfrm>
+            <a:off x="6858000" y="2935224"/>
+            <a:ext cx="2834640" cy="274320"/>
           </a:xfrm>
           <a:prstGeom prst="rect">
             <a:avLst/>
@@ -1508,14 +1650,14 @@
       </p:sp>
       <p:sp>
         <p:nvSpPr>
-          <p:cNvPr id="20" name="Text 17"/>
-          <p:cNvSpPr txBox="1"/>
-          <p:nvPr/>
-        </p:nvSpPr>
-        <p:spPr>
-          <a:xfrm>
-            <a:off x="9692640" y="2889504"/>
-            <a:ext cx="640080" cy="310896"/>
+          <p:cNvPr id="24" name="Text 21"/>
+          <p:cNvSpPr txBox="1"/>
+          <p:nvPr/>
+        </p:nvSpPr>
+        <p:spPr>
+          <a:xfrm>
+            <a:off x="9692640" y="2935224"/>
+            <a:ext cx="640080" cy="274320"/>
           </a:xfrm>
           <a:prstGeom prst="rect">
             <a:avLst/>
@@ -1547,14 +1689,14 @@
       </p:sp>
       <p:sp>
         <p:nvSpPr>
-          <p:cNvPr id="21" name="Text 18"/>
-          <p:cNvSpPr txBox="1"/>
-          <p:nvPr/>
-        </p:nvSpPr>
-        <p:spPr>
-          <a:xfrm>
-            <a:off x="10241280" y="2889504"/>
-            <a:ext cx="1463040" cy="310896"/>
+          <p:cNvPr id="25" name="Text 22"/>
+          <p:cNvSpPr txBox="1"/>
+          <p:nvPr/>
+        </p:nvSpPr>
+        <p:spPr>
+          <a:xfrm>
+            <a:off x="10241280" y="2935224"/>
+            <a:ext cx="1463040" cy="274320"/>
           </a:xfrm>
           <a:prstGeom prst="rect">
             <a:avLst/>
@@ -1586,14 +1728,14 @@
       </p:sp>
       <p:sp>
         <p:nvSpPr>
-          <p:cNvPr id="22" name="Shape 19"/>
+          <p:cNvPr id="26" name="Shape 23"/>
           <p:cNvSpPr/>
           <p:nvPr/>
         </p:nvSpPr>
         <p:spPr>
           <a:xfrm>
-            <a:off x="6583680" y="3291840"/>
-            <a:ext cx="182880" cy="182880"/>
+            <a:off x="6583680" y="3278124"/>
+            <a:ext cx="164592" cy="164592"/>
           </a:xfrm>
           <a:prstGeom prst="ellipse">
             <a:avLst/>
@@ -1611,14 +1753,14 @@
       </p:sp>
       <p:sp>
         <p:nvSpPr>
-          <p:cNvPr id="23" name="Text 20"/>
-          <p:cNvSpPr txBox="1"/>
-          <p:nvPr/>
-        </p:nvSpPr>
-        <p:spPr>
-          <a:xfrm>
-            <a:off x="6858000" y="3227832"/>
-            <a:ext cx="2834640" cy="310896"/>
+          <p:cNvPr id="27" name="Text 24"/>
+          <p:cNvSpPr txBox="1"/>
+          <p:nvPr/>
+        </p:nvSpPr>
+        <p:spPr>
+          <a:xfrm>
+            <a:off x="6858000" y="3223260"/>
+            <a:ext cx="2834640" cy="274320"/>
           </a:xfrm>
           <a:prstGeom prst="rect">
             <a:avLst/>
@@ -1650,14 +1792,14 @@
       </p:sp>
       <p:sp>
         <p:nvSpPr>
-          <p:cNvPr id="24" name="Text 21"/>
-          <p:cNvSpPr txBox="1"/>
-          <p:nvPr/>
-        </p:nvSpPr>
-        <p:spPr>
-          <a:xfrm>
-            <a:off x="9692640" y="3227832"/>
-            <a:ext cx="640080" cy="310896"/>
+          <p:cNvPr id="28" name="Text 25"/>
+          <p:cNvSpPr txBox="1"/>
+          <p:nvPr/>
+        </p:nvSpPr>
+        <p:spPr>
+          <a:xfrm>
+            <a:off x="9692640" y="3223260"/>
+            <a:ext cx="640080" cy="274320"/>
           </a:xfrm>
           <a:prstGeom prst="rect">
             <a:avLst/>
@@ -1689,14 +1831,14 @@
       </p:sp>
       <p:sp>
         <p:nvSpPr>
-          <p:cNvPr id="25" name="Text 22"/>
-          <p:cNvSpPr txBox="1"/>
-          <p:nvPr/>
-        </p:nvSpPr>
-        <p:spPr>
-          <a:xfrm>
-            <a:off x="10241280" y="3227832"/>
-            <a:ext cx="1463040" cy="310896"/>
+          <p:cNvPr id="29" name="Text 26"/>
+          <p:cNvSpPr txBox="1"/>
+          <p:nvPr/>
+        </p:nvSpPr>
+        <p:spPr>
+          <a:xfrm>
+            <a:off x="10241280" y="3223260"/>
+            <a:ext cx="1463040" cy="274320"/>
           </a:xfrm>
           <a:prstGeom prst="rect">
             <a:avLst/>
@@ -1728,14 +1870,14 @@
       </p:sp>
       <p:sp>
         <p:nvSpPr>
-          <p:cNvPr id="26" name="Shape 23"/>
+          <p:cNvPr id="30" name="Shape 27"/>
           <p:cNvSpPr/>
           <p:nvPr/>
         </p:nvSpPr>
         <p:spPr>
           <a:xfrm>
-            <a:off x="6583680" y="3630168"/>
-            <a:ext cx="182880" cy="182880"/>
+            <a:off x="6583680" y="3566160"/>
+            <a:ext cx="164592" cy="164592"/>
           </a:xfrm>
           <a:prstGeom prst="ellipse">
             <a:avLst/>
@@ -1753,14 +1895,14 @@
       </p:sp>
       <p:sp>
         <p:nvSpPr>
-          <p:cNvPr id="27" name="Text 24"/>
-          <p:cNvSpPr txBox="1"/>
-          <p:nvPr/>
-        </p:nvSpPr>
-        <p:spPr>
-          <a:xfrm>
-            <a:off x="6858000" y="3566160"/>
-            <a:ext cx="2834640" cy="310896"/>
+          <p:cNvPr id="31" name="Text 28"/>
+          <p:cNvSpPr txBox="1"/>
+          <p:nvPr/>
+        </p:nvSpPr>
+        <p:spPr>
+          <a:xfrm>
+            <a:off x="6858000" y="3511296"/>
+            <a:ext cx="2834640" cy="274320"/>
           </a:xfrm>
           <a:prstGeom prst="rect">
             <a:avLst/>
@@ -1792,14 +1934,14 @@
       </p:sp>
       <p:sp>
         <p:nvSpPr>
-          <p:cNvPr id="28" name="Text 25"/>
-          <p:cNvSpPr txBox="1"/>
-          <p:nvPr/>
-        </p:nvSpPr>
-        <p:spPr>
-          <a:xfrm>
-            <a:off x="9692640" y="3566160"/>
-            <a:ext cx="640080" cy="310896"/>
+          <p:cNvPr id="32" name="Text 29"/>
+          <p:cNvSpPr txBox="1"/>
+          <p:nvPr/>
+        </p:nvSpPr>
+        <p:spPr>
+          <a:xfrm>
+            <a:off x="9692640" y="3511296"/>
+            <a:ext cx="640080" cy="274320"/>
           </a:xfrm>
           <a:prstGeom prst="rect">
             <a:avLst/>
@@ -1831,14 +1973,14 @@
       </p:sp>
       <p:sp>
         <p:nvSpPr>
-          <p:cNvPr id="29" name="Text 26"/>
-          <p:cNvSpPr txBox="1"/>
-          <p:nvPr/>
-        </p:nvSpPr>
-        <p:spPr>
-          <a:xfrm>
-            <a:off x="10241280" y="3566160"/>
-            <a:ext cx="1463040" cy="310896"/>
+          <p:cNvPr id="33" name="Text 30"/>
+          <p:cNvSpPr txBox="1"/>
+          <p:nvPr/>
+        </p:nvSpPr>
+        <p:spPr>
+          <a:xfrm>
+            <a:off x="10241280" y="3511296"/>
+            <a:ext cx="1463040" cy="274320"/>
           </a:xfrm>
           <a:prstGeom prst="rect">
             <a:avLst/>
@@ -1870,14 +2012,14 @@
       </p:sp>
       <p:sp>
         <p:nvSpPr>
-          <p:cNvPr id="30" name="Shape 27"/>
+          <p:cNvPr id="34" name="Shape 31"/>
           <p:cNvSpPr/>
           <p:nvPr/>
         </p:nvSpPr>
         <p:spPr>
           <a:xfrm>
-            <a:off x="6583680" y="3968496"/>
-            <a:ext cx="182880" cy="182880"/>
+            <a:off x="6583680" y="3854196"/>
+            <a:ext cx="164592" cy="164592"/>
           </a:xfrm>
           <a:prstGeom prst="ellipse">
             <a:avLst/>
@@ -1895,14 +2037,14 @@
       </p:sp>
       <p:sp>
         <p:nvSpPr>
-          <p:cNvPr id="31" name="Text 28"/>
-          <p:cNvSpPr txBox="1"/>
-          <p:nvPr/>
-        </p:nvSpPr>
-        <p:spPr>
-          <a:xfrm>
-            <a:off x="6858000" y="3904488"/>
-            <a:ext cx="2834640" cy="310896"/>
+          <p:cNvPr id="35" name="Text 32"/>
+          <p:cNvSpPr txBox="1"/>
+          <p:nvPr/>
+        </p:nvSpPr>
+        <p:spPr>
+          <a:xfrm>
+            <a:off x="6858000" y="3799332"/>
+            <a:ext cx="2834640" cy="274320"/>
           </a:xfrm>
           <a:prstGeom prst="rect">
             <a:avLst/>
@@ -1934,14 +2076,14 @@
       </p:sp>
       <p:sp>
         <p:nvSpPr>
-          <p:cNvPr id="32" name="Text 29"/>
-          <p:cNvSpPr txBox="1"/>
-          <p:nvPr/>
-        </p:nvSpPr>
-        <p:spPr>
-          <a:xfrm>
-            <a:off x="9692640" y="3904488"/>
-            <a:ext cx="640080" cy="310896"/>
+          <p:cNvPr id="36" name="Text 33"/>
+          <p:cNvSpPr txBox="1"/>
+          <p:nvPr/>
+        </p:nvSpPr>
+        <p:spPr>
+          <a:xfrm>
+            <a:off x="9692640" y="3799332"/>
+            <a:ext cx="640080" cy="274320"/>
           </a:xfrm>
           <a:prstGeom prst="rect">
             <a:avLst/>
@@ -1973,14 +2115,14 @@
       </p:sp>
       <p:sp>
         <p:nvSpPr>
-          <p:cNvPr id="33" name="Text 30"/>
-          <p:cNvSpPr txBox="1"/>
-          <p:nvPr/>
-        </p:nvSpPr>
-        <p:spPr>
-          <a:xfrm>
-            <a:off x="10241280" y="3904488"/>
-            <a:ext cx="1463040" cy="310896"/>
+          <p:cNvPr id="37" name="Text 34"/>
+          <p:cNvSpPr txBox="1"/>
+          <p:nvPr/>
+        </p:nvSpPr>
+        <p:spPr>
+          <a:xfrm>
+            <a:off x="10241280" y="3799332"/>
+            <a:ext cx="1463040" cy="274320"/>
           </a:xfrm>
           <a:prstGeom prst="rect">
             <a:avLst/>
@@ -2012,14 +2154,14 @@
       </p:sp>
       <p:sp>
         <p:nvSpPr>
-          <p:cNvPr id="34" name="Shape 31"/>
+          <p:cNvPr id="38" name="Shape 35"/>
           <p:cNvSpPr/>
           <p:nvPr/>
         </p:nvSpPr>
         <p:spPr>
           <a:xfrm>
-            <a:off x="6583680" y="4306824"/>
-            <a:ext cx="182880" cy="182880"/>
+            <a:off x="6583680" y="4142232"/>
+            <a:ext cx="164592" cy="164592"/>
           </a:xfrm>
           <a:prstGeom prst="ellipse">
             <a:avLst/>
@@ -2037,14 +2179,14 @@
       </p:sp>
       <p:sp>
         <p:nvSpPr>
-          <p:cNvPr id="35" name="Text 32"/>
-          <p:cNvSpPr txBox="1"/>
-          <p:nvPr/>
-        </p:nvSpPr>
-        <p:spPr>
-          <a:xfrm>
-            <a:off x="6858000" y="4242816"/>
-            <a:ext cx="2834640" cy="310896"/>
+          <p:cNvPr id="39" name="Text 36"/>
+          <p:cNvSpPr txBox="1"/>
+          <p:nvPr/>
+        </p:nvSpPr>
+        <p:spPr>
+          <a:xfrm>
+            <a:off x="6858000" y="4087368"/>
+            <a:ext cx="2834640" cy="274320"/>
           </a:xfrm>
           <a:prstGeom prst="rect">
             <a:avLst/>
@@ -2076,14 +2218,14 @@
       </p:sp>
       <p:sp>
         <p:nvSpPr>
-          <p:cNvPr id="36" name="Text 33"/>
-          <p:cNvSpPr txBox="1"/>
-          <p:nvPr/>
-        </p:nvSpPr>
-        <p:spPr>
-          <a:xfrm>
-            <a:off x="9692640" y="4242816"/>
-            <a:ext cx="640080" cy="310896"/>
+          <p:cNvPr id="40" name="Text 37"/>
+          <p:cNvSpPr txBox="1"/>
+          <p:nvPr/>
+        </p:nvSpPr>
+        <p:spPr>
+          <a:xfrm>
+            <a:off x="9692640" y="4087368"/>
+            <a:ext cx="640080" cy="274320"/>
           </a:xfrm>
           <a:prstGeom prst="rect">
             <a:avLst/>
@@ -2115,14 +2257,14 @@
       </p:sp>
       <p:sp>
         <p:nvSpPr>
-          <p:cNvPr id="37" name="Text 34"/>
-          <p:cNvSpPr txBox="1"/>
-          <p:nvPr/>
-        </p:nvSpPr>
-        <p:spPr>
-          <a:xfrm>
-            <a:off x="10241280" y="4242816"/>
-            <a:ext cx="1463040" cy="310896"/>
+          <p:cNvPr id="41" name="Text 38"/>
+          <p:cNvSpPr txBox="1"/>
+          <p:nvPr/>
+        </p:nvSpPr>
+        <p:spPr>
+          <a:xfrm>
+            <a:off x="10241280" y="4087368"/>
+            <a:ext cx="1463040" cy="274320"/>
           </a:xfrm>
           <a:prstGeom prst="rect">
             <a:avLst/>
@@ -2154,14 +2296,14 @@
       </p:sp>
       <p:sp>
         <p:nvSpPr>
-          <p:cNvPr id="38" name="Shape 35"/>
+          <p:cNvPr id="42" name="Shape 39"/>
           <p:cNvSpPr/>
           <p:nvPr/>
         </p:nvSpPr>
         <p:spPr>
           <a:xfrm>
-            <a:off x="6583680" y="4645152"/>
-            <a:ext cx="182880" cy="182880"/>
+            <a:off x="6583680" y="4430268"/>
+            <a:ext cx="164592" cy="164592"/>
           </a:xfrm>
           <a:prstGeom prst="ellipse">
             <a:avLst/>
@@ -2179,14 +2321,14 @@
       </p:sp>
       <p:sp>
         <p:nvSpPr>
-          <p:cNvPr id="39" name="Text 36"/>
-          <p:cNvSpPr txBox="1"/>
-          <p:nvPr/>
-        </p:nvSpPr>
-        <p:spPr>
-          <a:xfrm>
-            <a:off x="6858000" y="4581144"/>
-            <a:ext cx="2834640" cy="310896"/>
+          <p:cNvPr id="43" name="Text 40"/>
+          <p:cNvSpPr txBox="1"/>
+          <p:nvPr/>
+        </p:nvSpPr>
+        <p:spPr>
+          <a:xfrm>
+            <a:off x="6858000" y="4375404"/>
+            <a:ext cx="2834640" cy="274320"/>
           </a:xfrm>
           <a:prstGeom prst="rect">
             <a:avLst/>
@@ -2218,14 +2360,14 @@
       </p:sp>
       <p:sp>
         <p:nvSpPr>
-          <p:cNvPr id="40" name="Text 37"/>
-          <p:cNvSpPr txBox="1"/>
-          <p:nvPr/>
-        </p:nvSpPr>
-        <p:spPr>
-          <a:xfrm>
-            <a:off x="9692640" y="4581144"/>
-            <a:ext cx="640080" cy="310896"/>
+          <p:cNvPr id="44" name="Text 41"/>
+          <p:cNvSpPr txBox="1"/>
+          <p:nvPr/>
+        </p:nvSpPr>
+        <p:spPr>
+          <a:xfrm>
+            <a:off x="9692640" y="4375404"/>
+            <a:ext cx="640080" cy="274320"/>
           </a:xfrm>
           <a:prstGeom prst="rect">
             <a:avLst/>
@@ -2257,14 +2399,14 @@
       </p:sp>
       <p:sp>
         <p:nvSpPr>
-          <p:cNvPr id="41" name="Text 38"/>
-          <p:cNvSpPr txBox="1"/>
-          <p:nvPr/>
-        </p:nvSpPr>
-        <p:spPr>
-          <a:xfrm>
-            <a:off x="10241280" y="4581144"/>
-            <a:ext cx="1463040" cy="310896"/>
+          <p:cNvPr id="45" name="Text 42"/>
+          <p:cNvSpPr txBox="1"/>
+          <p:nvPr/>
+        </p:nvSpPr>
+        <p:spPr>
+          <a:xfrm>
+            <a:off x="10241280" y="4375404"/>
+            <a:ext cx="1463040" cy="274320"/>
           </a:xfrm>
           <a:prstGeom prst="rect">
             <a:avLst/>
@@ -2296,24 +2438,24 @@
       </p:sp>
       <p:sp>
         <p:nvSpPr>
-          <p:cNvPr id="42" name="Shape 39"/>
+          <p:cNvPr id="46" name="Shape 43"/>
           <p:cNvSpPr/>
           <p:nvPr/>
         </p:nvSpPr>
         <p:spPr>
           <a:xfrm>
-            <a:off x="6583680" y="4983480"/>
-            <a:ext cx="182880" cy="182880"/>
+            <a:off x="6583680" y="4718304"/>
+            <a:ext cx="164592" cy="164592"/>
           </a:xfrm>
           <a:prstGeom prst="ellipse">
             <a:avLst/>
           </a:prstGeom>
           <a:solidFill>
-            <a:srgbClr val="1F2A44"/>
+            <a:srgbClr val="868E96"/>
           </a:solidFill>
           <a:ln w="12700">
             <a:solidFill>
-              <a:srgbClr val="1F2A44"/>
+              <a:srgbClr val="868E96"/>
             </a:solidFill>
             <a:prstDash val="solid"/>
           </a:ln>
@@ -2321,14 +2463,14 @@
       </p:sp>
       <p:sp>
         <p:nvSpPr>
-          <p:cNvPr id="43" name="Text 40"/>
-          <p:cNvSpPr txBox="1"/>
-          <p:nvPr/>
-        </p:nvSpPr>
-        <p:spPr>
-          <a:xfrm>
-            <a:off x="6858000" y="4919472"/>
-            <a:ext cx="2834640" cy="310896"/>
+          <p:cNvPr id="47" name="Text 44"/>
+          <p:cNvSpPr txBox="1"/>
+          <p:nvPr/>
+        </p:nvSpPr>
+        <p:spPr>
+          <a:xfrm>
+            <a:off x="6858000" y="4663440"/>
+            <a:ext cx="2834640" cy="274320"/>
           </a:xfrm>
           <a:prstGeom prst="rect">
             <a:avLst/>
@@ -2360,14 +2502,14 @@
       </p:sp>
       <p:sp>
         <p:nvSpPr>
-          <p:cNvPr id="44" name="Text 41"/>
-          <p:cNvSpPr txBox="1"/>
-          <p:nvPr/>
-        </p:nvSpPr>
-        <p:spPr>
-          <a:xfrm>
-            <a:off x="9692640" y="4919472"/>
-            <a:ext cx="640080" cy="310896"/>
+          <p:cNvPr id="48" name="Text 45"/>
+          <p:cNvSpPr txBox="1"/>
+          <p:nvPr/>
+        </p:nvSpPr>
+        <p:spPr>
+          <a:xfrm>
+            <a:off x="9692640" y="4663440"/>
+            <a:ext cx="640080" cy="274320"/>
           </a:xfrm>
           <a:prstGeom prst="rect">
             <a:avLst/>
@@ -2399,14 +2541,14 @@
       </p:sp>
       <p:sp>
         <p:nvSpPr>
-          <p:cNvPr id="45" name="Text 42"/>
-          <p:cNvSpPr txBox="1"/>
-          <p:nvPr/>
-        </p:nvSpPr>
-        <p:spPr>
-          <a:xfrm>
-            <a:off x="10241280" y="4919472"/>
-            <a:ext cx="1463040" cy="310896"/>
+          <p:cNvPr id="49" name="Text 46"/>
+          <p:cNvSpPr txBox="1"/>
+          <p:nvPr/>
+        </p:nvSpPr>
+        <p:spPr>
+          <a:xfrm>
+            <a:off x="10241280" y="4663440"/>
+            <a:ext cx="1463040" cy="274320"/>
           </a:xfrm>
           <a:prstGeom prst="rect">
             <a:avLst/>
@@ -2438,14 +2580,14 @@
       </p:sp>
       <p:sp>
         <p:nvSpPr>
-          <p:cNvPr id="46" name="Text 43"/>
-          <p:cNvSpPr txBox="1"/>
-          <p:nvPr/>
-        </p:nvSpPr>
-        <p:spPr>
-          <a:xfrm>
-            <a:off x="6583680" y="5193792"/>
-            <a:ext cx="5120640" cy="548640"/>
+          <p:cNvPr id="50" name="Text 47"/>
+          <p:cNvSpPr txBox="1"/>
+          <p:nvPr/>
+        </p:nvSpPr>
+        <p:spPr>
+          <a:xfrm>
+            <a:off x="6583680" y="4965192"/>
+            <a:ext cx="5120640" cy="457200"/>
           </a:xfrm>
           <a:prstGeom prst="rect">
             <a:avLst/>
@@ -2461,7 +2603,7 @@
               <a:buNone/>
             </a:pPr>
             <a:r>
-              <a:rPr lang="en-US" sz="3400" b="1" dirty="0">
+              <a:rPr lang="en-US" sz="2800" b="1" dirty="0">
                 <a:solidFill>
                   <a:srgbClr val="D6336C"/>
                 </a:solidFill>
@@ -2471,19 +2613,58 @@
               </a:rPr>
               <a:t>up to 10.2 dB</a:t>
             </a:r>
-            <a:endParaRPr lang="en-US" sz="3400" dirty="0"/>
-          </a:p>
-        </p:txBody>
-      </p:sp>
-      <p:sp>
-        <p:nvSpPr>
-          <p:cNvPr id="47" name="Text 44"/>
-          <p:cNvSpPr txBox="1"/>
-          <p:nvPr/>
-        </p:nvSpPr>
-        <p:spPr>
-          <a:xfrm>
-            <a:off x="6583680" y="5760720"/>
+            <a:endParaRPr lang="en-US" sz="2800" dirty="0"/>
+          </a:p>
+        </p:txBody>
+      </p:sp>
+      <p:sp>
+        <p:nvSpPr>
+          <p:cNvPr id="51" name="Text 48"/>
+          <p:cNvSpPr txBox="1"/>
+          <p:nvPr/>
+        </p:nvSpPr>
+        <p:spPr>
+          <a:xfrm>
+            <a:off x="6583680" y="5422392"/>
+            <a:ext cx="5120640" cy="365760"/>
+          </a:xfrm>
+          <a:prstGeom prst="rect">
+            <a:avLst/>
+          </a:prstGeom>
+          <a:noFill/>
+          <a:ln/>
+        </p:spPr>
+        <p:txBody>
+          <a:bodyPr wrap="square" lIns="0" tIns="0" rIns="0" bIns="0" rtlCol="0" anchor="t"/>
+          <a:lstStyle/>
+          <a:p>
+            <a:pPr indent="0" marL="0">
+              <a:buNone/>
+            </a:pPr>
+            <a:r>
+              <a:rPr lang="en-US" sz="1100" dirty="0">
+                <a:solidFill>
+                  <a:srgbClr val="1F2A44"/>
+                </a:solidFill>
+                <a:latin typeface="Calibri" pitchFamily="34" charset="0"/>
+                <a:ea typeface="Calibri" pitchFamily="34" charset="-122"/>
+                <a:cs typeface="Calibri" pitchFamily="34" charset="-120"/>
+              </a:rPr>
+              <a:t>best against worst membrane set-up (Thinsulate, 4 layers and Duct, membrane only), at +18°; 6.7 dB on average</a:t>
+            </a:r>
+            <a:endParaRPr lang="en-US" sz="1100" dirty="0"/>
+          </a:p>
+        </p:txBody>
+      </p:sp>
+      <p:sp>
+        <p:nvSpPr>
+          <p:cNvPr id="52" name="Text 49"/>
+          <p:cNvSpPr txBox="1"/>
+          <p:nvPr/>
+        </p:nvSpPr>
+        <p:spPr>
+          <a:xfrm>
+            <a:off x="6583680" y="5824728"/>
             <a:ext cx="5120640" cy="457200"/>
           </a:xfrm>
           <a:prstGeom prst="rect">
@@ -2500,7 +2681,7 @@
               <a:buNone/>
             </a:pPr>
             <a:r>
-              <a:rPr lang="en-US" sz="1300" dirty="0">
+              <a:rPr lang="en-US" sz="1200" b="1" dirty="0">
                 <a:solidFill>
                   <a:srgbClr val="1F2A44"/>
                 </a:solidFill>
@@ -2508,15 +2689,29 @@
                 <a:ea typeface="Calibri" pitchFamily="34" charset="-122"/>
                 <a:cs typeface="Calibri" pitchFamily="34" charset="-120"/>
               </a:rPr>
-              <a:t>best (Thinsulate, 4 layers) against worst (Duct, membrane only), at +18°; 6.7 dB on average</a:t>
-            </a:r>
-            <a:endParaRPr lang="en-US" sz="1300" dirty="0"/>
-          </a:p>
-        </p:txBody>
-      </p:sp>
-      <p:sp>
-        <p:nvSpPr>
-          <p:cNvPr id="48" name="Text 45"/>
+              <a:t>Thrust at 2000 µs: </a:t>
+            </a:r>
+            <a:pPr indent="0" marL="0">
+              <a:buNone/>
+            </a:pPr>
+            <a:r>
+              <a:rPr lang="en-US" sz="1200" dirty="0">
+                <a:solidFill>
+                  <a:srgbClr val="1F2A44"/>
+                </a:solidFill>
+                <a:latin typeface="Calibri" pitchFamily="34" charset="0"/>
+                <a:ea typeface="Calibri" pitchFamily="34" charset="-122"/>
+                <a:cs typeface="Calibri" pitchFamily="34" charset="-120"/>
+              </a:rPr>
+              <a:t>bare prop 3.75 N. The quietest other set-up, Thinsulate 4 layers, only 0.39 N.</a:t>
+            </a:r>
+            <a:endParaRPr lang="en-US" sz="1200" dirty="0"/>
+          </a:p>
+        </p:txBody>
+      </p:sp>
+      <p:sp>
+        <p:nvSpPr>
+          <p:cNvPr id="53" name="Text 50"/>
           <p:cNvSpPr txBox="1"/>
           <p:nvPr/>
         </p:nvSpPr>
@@ -2547,7 +2742,7 @@
                 <a:ea typeface="Calibri" pitchFamily="34" charset="-122"/>
                 <a:cs typeface="Calibri" pitchFamily="34" charset="-120"/>
               </a:rPr>
-              <a:t>8 and 9 Oct 2026, 5-inch 3-blade propeller, 500 Hz–24 kHz, 2000 µs, mean of 3 repeats, corrected files. Axis 76–94 dB. Not comparable with slide 8.</a:t>
+              <a:t>8 and 9 Oct 2026, 5-inch 3-blade propeller, 500 Hz–24 kHz, 2000 µs, mean of 3 repeats, corrected files. Axis 69–94 dB. Not comparable with slide 8.</a:t>
             </a:r>
             <a:endParaRPr lang="en-US" sz="1100" dirty="0"/>
           </a:p>
@@ -2555,7 +2750,7 @@
       </p:sp>
       <p:sp>
         <p:nvSpPr>
-          <p:cNvPr id="49" name="Text 46"/>
+          <p:cNvPr id="54" name="Text 51"/>
           <p:cNvSpPr txBox="1"/>
           <p:nvPr/>
         </p:nvSpPr>

</xml_diff>